<commit_message>
corrected the order of the sections
</commit_message>
<xml_diff>
--- a/chapter_03/figures/break_down_scores.pptx
+++ b/chapter_03/figures/break_down_scores.pptx
@@ -125,12 +125,12 @@
   <pc:docChgLst>
     <pc:chgData name="Fatima Pillosu" userId="a6295d4dc9e22643" providerId="LiveId" clId="{87453732-75AC-4426-B5D3-B7C69C2D4F54}"/>
     <pc:docChg chg="undo custSel modSld">
-      <pc:chgData name="Fatima Pillosu" userId="a6295d4dc9e22643" providerId="LiveId" clId="{87453732-75AC-4426-B5D3-B7C69C2D4F54}" dt="2026-01-20T00:06:27.992" v="144"/>
+      <pc:chgData name="Fatima Pillosu" userId="a6295d4dc9e22643" providerId="LiveId" clId="{87453732-75AC-4426-B5D3-B7C69C2D4F54}" dt="2026-01-20T00:07:31.550" v="145" actId="20577"/>
       <pc:docMkLst>
         <pc:docMk/>
       </pc:docMkLst>
       <pc:sldChg chg="addSp delSp modSp mod">
-        <pc:chgData name="Fatima Pillosu" userId="a6295d4dc9e22643" providerId="LiveId" clId="{87453732-75AC-4426-B5D3-B7C69C2D4F54}" dt="2026-01-20T00:06:27.992" v="144"/>
+        <pc:chgData name="Fatima Pillosu" userId="a6295d4dc9e22643" providerId="LiveId" clId="{87453732-75AC-4426-B5D3-B7C69C2D4F54}" dt="2026-01-20T00:07:31.550" v="145" actId="20577"/>
         <pc:sldMkLst>
           <pc:docMk/>
           <pc:sldMk cId="1573992039" sldId="256"/>
@@ -623,6 +623,14 @@
             <ac:spMk id="1041" creationId="{1E5D66FA-EFC0-033C-8CCA-7AD9A29FE854}"/>
           </ac:spMkLst>
         </pc:spChg>
+        <pc:spChg chg="mod">
+          <ac:chgData name="Fatima Pillosu" userId="a6295d4dc9e22643" providerId="LiveId" clId="{87453732-75AC-4426-B5D3-B7C69C2D4F54}" dt="2026-01-20T00:07:31.550" v="145" actId="20577"/>
+          <ac:spMkLst>
+            <pc:docMk/>
+            <pc:sldMk cId="1573992039" sldId="256"/>
+            <ac:spMk id="1046" creationId="{F4E1EB47-FB49-B221-8F40-6FAAC8188E34}"/>
+          </ac:spMkLst>
+        </pc:spChg>
         <pc:spChg chg="add mod">
           <ac:chgData name="Fatima Pillosu" userId="a6295d4dc9e22643" providerId="LiveId" clId="{87453732-75AC-4426-B5D3-B7C69C2D4F54}" dt="2026-01-20T00:06:27.992" v="144"/>
           <ac:spMkLst>
@@ -3853,6 +3861,19 @@
           <a:lstStyle/>
           <a:p>
             <a:r>
+              <a:rPr lang="en-US" sz="1200" b="1">
+                <a:solidFill>
+                  <a:schemeClr val="tx1">
+                    <a:lumMod val="95000"/>
+                    <a:lumOff val="5000"/>
+                  </a:schemeClr>
+                </a:solidFill>
+                <a:latin typeface="Calibri" panose="020F0502020204030204" pitchFamily="34" charset="0"/>
+                <a:cs typeface="Calibri" panose="020F0502020204030204" pitchFamily="34" charset="0"/>
+              </a:rPr>
+              <a:t>Breakdown </a:t>
+            </a:r>
+            <a:r>
               <a:rPr lang="en-US" sz="1200" b="1" dirty="0">
                 <a:solidFill>
                   <a:schemeClr val="tx1">
@@ -3863,7 +3884,7 @@
                 <a:latin typeface="Calibri" panose="020F0502020204030204" pitchFamily="34" charset="0"/>
                 <a:cs typeface="Calibri" panose="020F0502020204030204" pitchFamily="34" charset="0"/>
               </a:rPr>
-              <a:t>Break down scores</a:t>
+              <a:t>scores</a:t>
             </a:r>
           </a:p>
           <a:p>

</xml_diff>